<commit_message>
E-T2: domain elasticity measured — transfer proven, menu-lattice observed; theory deck slide-5 rewired to measurements
Co-Authored-By: Claude Fable 5 <noreply@anthropic.com>
</commit_message>
<xml_diff>
--- a/docs/theory_deck.pptx
+++ b/docs/theory_deck.pptx
@@ -3131,7 +3131,7 @@
               <a:defRPr sz="1700"/>
             </a:pPr>
             <a:r>
-              <a:t>N차원 key 공간의 기저 재선택으로서의 R — 통신 통계, 암묵적 고유분해, Davis-Kahan 일반화 논증</a:t>
+              <a:t>N차원 key 공간의 기저 재선택으로서의 R — 통신 통계, loss-정의 중요도(E-T1), 도메인 이식 실측(E-T2)</a:t>
             </a:r>
           </a:p>
           <a:p>
@@ -3835,7 +3835,7 @@
               </a:defRPr>
             </a:pPr>
             <a:r>
-              <a:t>5. 왜 과적합되지 않는가 (1) — 배우는 것이 '부분공간'이라서</a:t>
+              <a:t>5. 왜 과적합되지 않는가 (1) — 갭 논증이 아니라 '작은 가설류 + 이식 실측'</a:t>
             </a:r>
           </a:p>
         </p:txBody>
@@ -3863,7 +3863,7 @@
           <a:lstStyle/>
           <a:p>
             <a:pPr>
-              <a:defRPr sz="1400"/>
+              <a:defRPr sz="1300"/>
             </a:pPr>
             <a:r>
               <a:t>R의 가설 공간 = 직교군 (3.5M, 백본의 0.04%) — 특징을 새로 배우지 않고 기존 통계의 좌표만 고름</a:t>
@@ -3871,25 +3871,25 @@
           </a:p>
           <a:p>
             <a:pPr>
-              <a:defRPr sz="1400"/>
+              <a:defRPr sz="1300"/>
             </a:pPr>
             <a:r>
-              <a:t>고유공간 추정은 표본 집중(행렬 농도부등식)으로 수렴하고, Davis-Kahan sin-θ 정리: 고유값 갭이 크면 분포 섭동에도 부분공간이 안정</a:t>
+              <a:t>이상화(Davis-Kahan): 갭 크면 부분공간 안정 — 실측이 기각: 명시 M은 gap@32≈0, 학습 R과 주각 cos 0.44≈무작위 (lag-0·시차·열노름·질의에너지 4중 수렴) → 중요도는 loss가 정의, training-free 통계로 대체 불가</a:t>
             </a:r>
           </a:p>
           <a:p>
             <a:pPr>
-              <a:defRPr sz="1400"/>
+              <a:defRPr sz="1300"/>
             </a:pPr>
             <a:r>
-              <a:t>예측(검증 가능): 추정된 M의 스펙트럼에서 n=32 경계의 갭 측정 → 갭 큼 = 이식성 보장</a:t>
+              <a:t>일반화의 실제 근거 = ① 가설류 작음 ② 이식의 직접 실측(E-T2): 한 R의 절단세 곡선이 wiki/수학/코드에서 겹침 (k16: 1.26/1.31/1.27×) vs calibration 기저는 k16에서 17-36× 절벽</a:t>
             </a:r>
           </a:p>
         </p:txBody>
       </p:sp>
       <p:pic>
         <p:nvPicPr>
-          <p:cNvPr id="4" name="Picture 3" descr="F5_dk.png"/>
+          <p:cNvPr id="4" name="Picture 3" descr="F5_measured.png"/>
           <p:cNvPicPr>
             <a:picLocks noChangeAspect="1"/>
           </p:cNvPicPr>
@@ -3903,8 +3903,8 @@
         </p:blipFill>
         <p:spPr>
           <a:xfrm>
-            <a:off x="1520230" y="2423160"/>
-            <a:ext cx="9151234" cy="4206240"/>
+            <a:off x="1146179" y="2423160"/>
+            <a:ext cx="9899336" cy="4206240"/>
           </a:xfrm>
           <a:prstGeom prst="rect">
             <a:avLst/>
@@ -3987,7 +3987,7 @@
           <a:lstStyle/>
           <a:p>
             <a:pPr>
-              <a:defRPr sz="1400"/>
+              <a:defRPr sz="1300"/>
             </a:pPr>
             <a:r>
               <a:t>hot은 방향 1개가 아닌 그룹당 32차원 부분공간 — hot 내부 순서는 무의미, 경계만 유효</a:t>
@@ -3995,7 +3995,7 @@
           </a:p>
           <a:p>
             <a:pPr>
-              <a:defRPr sz="1400"/>
+              <a:defRPr sz="1300"/>
             </a:pPr>
             <a:r>
               <a:t>태스크들이 서로 다른 순서로 밀어도 상위 방향 합집합이 32차원에 들어오면 무충돌 + 27층×8그룹이 다양성 분산 흡수</a:t>
@@ -4003,10 +4003,18 @@
           </a:p>
           <a:p>
             <a:pPr>
-              <a:defRPr sz="1400"/>
+              <a:defRPr sz="1300"/>
             </a:pPr>
             <a:r>
               <a:t>실증: 일반 LM loss로만 학습한 R이 GSM8K/RULER/recall/HumanEval 전반 lossless — 상위 스펙트럼 = 태스크 공유 인프라</a:t>
+            </a:r>
+          </a:p>
+          <a:p>
+            <a:pPr>
+              <a:defRPr sz="1300"/>
+            </a:pPr>
+            <a:r>
+              <a:t>정밀화(E-T2): 배우는 것은 전순서도 아닌 '메뉴 격자의 부분공간 사슬(flag)' — 메뉴 밖 폭(k=8, 96)은 3도메인 공통으로 유료(k96 1.2-1.4× &gt; k64) → 학습이 굽는 건 메뉴 지점의 경계들뿐</a:t>
             </a:r>
           </a:p>
         </p:txBody>
@@ -4027,8 +4035,8 @@
         </p:blipFill>
         <p:spPr>
           <a:xfrm>
-            <a:off x="1913371" y="2423160"/>
-            <a:ext cx="8364951" cy="4206240"/>
+            <a:off x="2277065" y="2788920"/>
+            <a:ext cx="7637564" cy="3840480"/>
           </a:xfrm>
           <a:prstGeom prst="rect">
             <a:avLst/>
@@ -4250,7 +4258,7 @@
               <a:defRPr sz="1500"/>
             </a:pPr>
             <a:r>
-              <a:t>[논증+실측]  일반화 (혼합→다운스트림)  —  부분공간 가설류(작음) + Davis-Kahan 안정성 + LM-only R의 이식 실측</a:t>
+              <a:t>[확정(실측)]  중요도 = loss-정의 (E-T1)  —  명시 M(lag-0·시차)·열노름·질의에너지 전부 학습 R과 무상관(cos 0.44) — calibration류 실패의 뿌리</a:t>
             </a:r>
           </a:p>
           <a:p>
@@ -4261,7 +4269,7 @@
               <a:defRPr sz="1500"/>
             </a:pPr>
             <a:r>
-              <a:t>[확정]  경계 민감성  —  wikitext 실패 / longcot 회복 — 재현 가능한 레시피 실측</a:t>
+              <a:t>[확정(실측)]  일반화 (혼합→다운스트림)  —  부분공간 가설류(작음) + E-T2 이식 실측(3도메인 tax 곡선 일치) + LM-only R 전이; D-K 갭 논증은 기각(gap@32≈0)</a:t>
             </a:r>
           </a:p>
           <a:p>
@@ -4272,7 +4280,29 @@
               <a:defRPr sz="1500"/>
             </a:pPr>
             <a:r>
-              <a:t>[TODO]  남은 이론 실험  —  ① M 명시 추정→n=32 갭 측정 ② spectral warm-start ③ M_task 정렬도(부분공간 각도) 측정</a:t>
+              <a:t>[관측]  메뉴 격자 (E-T2)  —  off-menu 폭(8, 96)은 3도메인 공통 유료 — 학습물 = 전순서가 아닌 메뉴 지점의 flag</a:t>
+            </a:r>
+          </a:p>
+          <a:p>
+            <a:pPr>
+              <a:spcAft>
+                <a:spcPts val="1200"/>
+              </a:spcAft>
+              <a:defRPr sz="1500"/>
+            </a:pPr>
+            <a:r>
+              <a:t>[확정]  경계 민감성  —  wikitext 실패 / longcot 회복 — 재현 가능한 레시피 실측</a:t>
+            </a:r>
+          </a:p>
+          <a:p>
+            <a:pPr>
+              <a:spcAft>
+                <a:spcPts val="1200"/>
+              </a:spcAft>
+              <a:defRPr sz="1500"/>
+            </a:pPr>
+            <a:r>
+              <a:t>[TODO]  남은 이론 실험  —  ① ppl-acc 괴리 정량화(ghost k32: ppl 1.3×인데 GSM8K −26.5) ② M_task 정렬도(부분공간 각도) ③ 경계갭 없는 안정성의 대안 정리(flag 최적성)</a:t>
             </a:r>
           </a:p>
         </p:txBody>

</xml_diff>